<commit_message>
Mise en place du chrono Megaptera et icones
</commit_message>
<xml_diff>
--- a/icons/20240723-iconesPNMC.pptx
+++ b/icons/20240723-iconesPNMC.pptx
@@ -5,10 +5,11 @@
     <p:sldMasterId id="2147483648" r:id="rId1"/>
   </p:sldMasterIdLst>
   <p:sldIdLst>
-    <p:sldId id="256" r:id="rId2"/>
-    <p:sldId id="259" r:id="rId3"/>
-    <p:sldId id="257" r:id="rId4"/>
-    <p:sldId id="258" r:id="rId5"/>
+    <p:sldId id="260" r:id="rId2"/>
+    <p:sldId id="256" r:id="rId3"/>
+    <p:sldId id="259" r:id="rId4"/>
+    <p:sldId id="257" r:id="rId5"/>
+    <p:sldId id="258" r:id="rId6"/>
   </p:sldIdLst>
   <p:sldSz cx="12192000" cy="6858000"/>
   <p:notesSz cx="6858000" cy="9144000"/>
@@ -244,7 +245,7 @@
           <a:p>
             <a:fld id="{D69CC91C-3FCF-491C-901A-4654FCD0FDAC}" type="datetimeFigureOut">
               <a:rPr lang="fr-FR" smtClean="0"/>
-              <a:t>30/10/2025</a:t>
+              <a:t>24/06/2026</a:t>
             </a:fld>
             <a:endParaRPr lang="fr-FR"/>
           </a:p>
@@ -412,7 +413,7 @@
           <a:p>
             <a:fld id="{D69CC91C-3FCF-491C-901A-4654FCD0FDAC}" type="datetimeFigureOut">
               <a:rPr lang="fr-FR" smtClean="0"/>
-              <a:t>30/10/2025</a:t>
+              <a:t>24/06/2026</a:t>
             </a:fld>
             <a:endParaRPr lang="fr-FR"/>
           </a:p>
@@ -590,7 +591,7 @@
           <a:p>
             <a:fld id="{D69CC91C-3FCF-491C-901A-4654FCD0FDAC}" type="datetimeFigureOut">
               <a:rPr lang="fr-FR" smtClean="0"/>
-              <a:t>30/10/2025</a:t>
+              <a:t>24/06/2026</a:t>
             </a:fld>
             <a:endParaRPr lang="fr-FR"/>
           </a:p>
@@ -758,7 +759,7 @@
           <a:p>
             <a:fld id="{D69CC91C-3FCF-491C-901A-4654FCD0FDAC}" type="datetimeFigureOut">
               <a:rPr lang="fr-FR" smtClean="0"/>
-              <a:t>30/10/2025</a:t>
+              <a:t>24/06/2026</a:t>
             </a:fld>
             <a:endParaRPr lang="fr-FR"/>
           </a:p>
@@ -1003,7 +1004,7 @@
           <a:p>
             <a:fld id="{D69CC91C-3FCF-491C-901A-4654FCD0FDAC}" type="datetimeFigureOut">
               <a:rPr lang="fr-FR" smtClean="0"/>
-              <a:t>30/10/2025</a:t>
+              <a:t>24/06/2026</a:t>
             </a:fld>
             <a:endParaRPr lang="fr-FR"/>
           </a:p>
@@ -1232,7 +1233,7 @@
           <a:p>
             <a:fld id="{D69CC91C-3FCF-491C-901A-4654FCD0FDAC}" type="datetimeFigureOut">
               <a:rPr lang="fr-FR" smtClean="0"/>
-              <a:t>30/10/2025</a:t>
+              <a:t>24/06/2026</a:t>
             </a:fld>
             <a:endParaRPr lang="fr-FR"/>
           </a:p>
@@ -1596,7 +1597,7 @@
           <a:p>
             <a:fld id="{D69CC91C-3FCF-491C-901A-4654FCD0FDAC}" type="datetimeFigureOut">
               <a:rPr lang="fr-FR" smtClean="0"/>
-              <a:t>30/10/2025</a:t>
+              <a:t>24/06/2026</a:t>
             </a:fld>
             <a:endParaRPr lang="fr-FR"/>
           </a:p>
@@ -1713,7 +1714,7 @@
           <a:p>
             <a:fld id="{D69CC91C-3FCF-491C-901A-4654FCD0FDAC}" type="datetimeFigureOut">
               <a:rPr lang="fr-FR" smtClean="0"/>
-              <a:t>30/10/2025</a:t>
+              <a:t>24/06/2026</a:t>
             </a:fld>
             <a:endParaRPr lang="fr-FR"/>
           </a:p>
@@ -1808,7 +1809,7 @@
           <a:p>
             <a:fld id="{D69CC91C-3FCF-491C-901A-4654FCD0FDAC}" type="datetimeFigureOut">
               <a:rPr lang="fr-FR" smtClean="0"/>
-              <a:t>30/10/2025</a:t>
+              <a:t>24/06/2026</a:t>
             </a:fld>
             <a:endParaRPr lang="fr-FR"/>
           </a:p>
@@ -2083,7 +2084,7 @@
           <a:p>
             <a:fld id="{D69CC91C-3FCF-491C-901A-4654FCD0FDAC}" type="datetimeFigureOut">
               <a:rPr lang="fr-FR" smtClean="0"/>
-              <a:t>30/10/2025</a:t>
+              <a:t>24/06/2026</a:t>
             </a:fld>
             <a:endParaRPr lang="fr-FR"/>
           </a:p>
@@ -2335,7 +2336,7 @@
           <a:p>
             <a:fld id="{D69CC91C-3FCF-491C-901A-4654FCD0FDAC}" type="datetimeFigureOut">
               <a:rPr lang="fr-FR" smtClean="0"/>
-              <a:t>30/10/2025</a:t>
+              <a:t>24/06/2026</a:t>
             </a:fld>
             <a:endParaRPr lang="fr-FR"/>
           </a:p>
@@ -2546,7 +2547,7 @@
           <a:p>
             <a:fld id="{D69CC91C-3FCF-491C-901A-4654FCD0FDAC}" type="datetimeFigureOut">
               <a:rPr lang="fr-FR" smtClean="0"/>
-              <a:t>30/10/2025</a:t>
+              <a:t>24/06/2026</a:t>
             </a:fld>
             <a:endParaRPr lang="fr-FR"/>
           </a:p>
@@ -2937,6 +2938,207 @@
 <file path=ppt/slides/slide1.xml><?xml version="1.0" encoding="utf-8"?>
 <p:sld xmlns:a="http://schemas.openxmlformats.org/drawingml/2006/main" xmlns:r="http://schemas.openxmlformats.org/officeDocument/2006/relationships" xmlns:p="http://schemas.openxmlformats.org/presentationml/2006/main">
   <p:cSld>
+    <p:bg>
+      <p:bgPr>
+        <a:solidFill>
+          <a:schemeClr val="accent4">
+            <a:lumMod val="20000"/>
+            <a:lumOff val="80000"/>
+          </a:schemeClr>
+        </a:solidFill>
+        <a:effectLst/>
+      </p:bgPr>
+    </p:bg>
+    <p:spTree>
+      <p:nvGrpSpPr>
+        <p:cNvPr id="1" name=""/>
+        <p:cNvGrpSpPr/>
+        <p:nvPr/>
+      </p:nvGrpSpPr>
+      <p:grpSpPr>
+        <a:xfrm>
+          <a:off x="0" y="0"/>
+          <a:ext cx="0" cy="0"/>
+          <a:chOff x="0" y="0"/>
+          <a:chExt cx="0" cy="0"/>
+        </a:xfrm>
+      </p:grpSpPr>
+      <p:pic>
+        <p:nvPicPr>
+          <p:cNvPr id="4" name="Image 3">
+            <a:extLst>
+              <a:ext uri="{FF2B5EF4-FFF2-40B4-BE49-F238E27FC236}">
+                <a16:creationId xmlns:a16="http://schemas.microsoft.com/office/drawing/2014/main" id="{845CD14B-3CFC-4C0D-B4BF-0C3D51A3E979}"/>
+              </a:ext>
+            </a:extLst>
+          </p:cNvPr>
+          <p:cNvPicPr>
+            <a:picLocks noChangeAspect="1"/>
+          </p:cNvPicPr>
+          <p:nvPr/>
+        </p:nvPicPr>
+        <p:blipFill>
+          <a:blip r:embed="rId2">
+            <a:clrChange>
+              <a:clrFrom>
+                <a:srgbClr val="FFFFFF"/>
+              </a:clrFrom>
+              <a:clrTo>
+                <a:srgbClr val="FFFFFF">
+                  <a:alpha val="0"/>
+                </a:srgbClr>
+              </a:clrTo>
+            </a:clrChange>
+          </a:blip>
+          <a:stretch>
+            <a:fillRect/>
+          </a:stretch>
+        </p:blipFill>
+        <p:spPr>
+          <a:xfrm>
+            <a:off x="88096" y="3170194"/>
+            <a:ext cx="4123215" cy="2861005"/>
+          </a:xfrm>
+          <a:prstGeom prst="rect">
+            <a:avLst/>
+          </a:prstGeom>
+        </p:spPr>
+      </p:pic>
+      <p:pic>
+        <p:nvPicPr>
+          <p:cNvPr id="5" name="Image 4">
+            <a:extLst>
+              <a:ext uri="{FF2B5EF4-FFF2-40B4-BE49-F238E27FC236}">
+                <a16:creationId xmlns:a16="http://schemas.microsoft.com/office/drawing/2014/main" id="{230ECE2C-EA46-4F3C-9E96-3595B3BEA20B}"/>
+              </a:ext>
+            </a:extLst>
+          </p:cNvPr>
+          <p:cNvPicPr>
+            <a:picLocks noChangeAspect="1"/>
+          </p:cNvPicPr>
+          <p:nvPr/>
+        </p:nvPicPr>
+        <p:blipFill>
+          <a:blip r:embed="rId2">
+            <a:clrChange>
+              <a:clrFrom>
+                <a:srgbClr val="FFFFFF"/>
+              </a:clrFrom>
+              <a:clrTo>
+                <a:srgbClr val="FFFFFF">
+                  <a:alpha val="0"/>
+                </a:srgbClr>
+              </a:clrTo>
+            </a:clrChange>
+            <a:duotone>
+              <a:schemeClr val="accent2">
+                <a:shade val="45000"/>
+                <a:satMod val="135000"/>
+              </a:schemeClr>
+              <a:prstClr val="white"/>
+            </a:duotone>
+          </a:blip>
+          <a:stretch>
+            <a:fillRect/>
+          </a:stretch>
+        </p:blipFill>
+        <p:spPr>
+          <a:xfrm flipH="1">
+            <a:off x="5157388" y="3007489"/>
+            <a:ext cx="4123215" cy="2861005"/>
+          </a:xfrm>
+          <a:prstGeom prst="rect">
+            <a:avLst/>
+          </a:prstGeom>
+        </p:spPr>
+      </p:pic>
+      <p:pic>
+        <p:nvPicPr>
+          <p:cNvPr id="7" name="Image 6">
+            <a:extLst>
+              <a:ext uri="{FF2B5EF4-FFF2-40B4-BE49-F238E27FC236}">
+                <a16:creationId xmlns:a16="http://schemas.microsoft.com/office/drawing/2014/main" id="{A990553F-0AE8-4A8C-9DC1-53439B2A7984}"/>
+              </a:ext>
+            </a:extLst>
+          </p:cNvPr>
+          <p:cNvPicPr>
+            <a:picLocks noChangeAspect="1"/>
+          </p:cNvPicPr>
+          <p:nvPr/>
+        </p:nvPicPr>
+        <p:blipFill>
+          <a:blip r:embed="rId3">
+            <a:clrChange>
+              <a:clrFrom>
+                <a:srgbClr val="FFFFFF"/>
+              </a:clrFrom>
+              <a:clrTo>
+                <a:srgbClr val="FFFFFF">
+                  <a:alpha val="0"/>
+                </a:srgbClr>
+              </a:clrTo>
+            </a:clrChange>
+          </a:blip>
+          <a:stretch>
+            <a:fillRect/>
+          </a:stretch>
+        </p:blipFill>
+        <p:spPr>
+          <a:xfrm>
+            <a:off x="262461" y="386050"/>
+            <a:ext cx="5297872" cy="2861005"/>
+          </a:xfrm>
+          <a:prstGeom prst="rect">
+            <a:avLst/>
+          </a:prstGeom>
+        </p:spPr>
+      </p:pic>
+      <p:pic>
+        <p:nvPicPr>
+          <p:cNvPr id="2" name="Image 1">
+            <a:extLst>
+              <a:ext uri="{FF2B5EF4-FFF2-40B4-BE49-F238E27FC236}">
+                <a16:creationId xmlns:a16="http://schemas.microsoft.com/office/drawing/2014/main" id="{88A7A90B-912A-4DCF-93BA-D53916DDDD28}"/>
+              </a:ext>
+            </a:extLst>
+          </p:cNvPr>
+          <p:cNvPicPr>
+            <a:picLocks noChangeAspect="1"/>
+          </p:cNvPicPr>
+          <p:nvPr/>
+        </p:nvPicPr>
+        <p:blipFill>
+          <a:blip r:embed="rId4"/>
+          <a:stretch>
+            <a:fillRect/>
+          </a:stretch>
+        </p:blipFill>
+        <p:spPr>
+          <a:xfrm>
+            <a:off x="6226087" y="494478"/>
+            <a:ext cx="4729701" cy="1202291"/>
+          </a:xfrm>
+          <a:prstGeom prst="rect">
+            <a:avLst/>
+          </a:prstGeom>
+        </p:spPr>
+      </p:pic>
+    </p:spTree>
+    <p:extLst>
+      <p:ext uri="{BB962C8B-B14F-4D97-AF65-F5344CB8AC3E}">
+        <p14:creationId xmlns:p14="http://schemas.microsoft.com/office/powerpoint/2010/main" val="3449247049"/>
+      </p:ext>
+    </p:extLst>
+  </p:cSld>
+  <p:clrMapOvr>
+    <a:masterClrMapping/>
+  </p:clrMapOvr>
+</p:sld>
+</file>
+
+<file path=ppt/slides/slide2.xml><?xml version="1.0" encoding="utf-8"?>
+<p:sld xmlns:a="http://schemas.openxmlformats.org/drawingml/2006/main" xmlns:r="http://schemas.openxmlformats.org/officeDocument/2006/relationships" xmlns:p="http://schemas.openxmlformats.org/presentationml/2006/main">
+  <p:cSld>
     <p:spTree>
       <p:nvGrpSpPr>
         <p:cNvPr id="1" name=""/>
@@ -3145,7 +3347,7 @@
 </p:sld>
 </file>
 
-<file path=ppt/slides/slide2.xml><?xml version="1.0" encoding="utf-8"?>
+<file path=ppt/slides/slide3.xml><?xml version="1.0" encoding="utf-8"?>
 <p:sld xmlns:a="http://schemas.openxmlformats.org/drawingml/2006/main" xmlns:r="http://schemas.openxmlformats.org/officeDocument/2006/relationships" xmlns:p="http://schemas.openxmlformats.org/presentationml/2006/main">
   <p:cSld>
     <p:spTree>
@@ -3348,7 +3550,7 @@
 </p:sld>
 </file>
 
-<file path=ppt/slides/slide3.xml><?xml version="1.0" encoding="utf-8"?>
+<file path=ppt/slides/slide4.xml><?xml version="1.0" encoding="utf-8"?>
 <p:sld xmlns:a="http://schemas.openxmlformats.org/drawingml/2006/main" xmlns:r="http://schemas.openxmlformats.org/officeDocument/2006/relationships" xmlns:p="http://schemas.openxmlformats.org/presentationml/2006/main">
   <p:cSld>
     <p:spTree>
@@ -4242,7 +4444,7 @@
 </p:sld>
 </file>
 
-<file path=ppt/slides/slide4.xml><?xml version="1.0" encoding="utf-8"?>
+<file path=ppt/slides/slide5.xml><?xml version="1.0" encoding="utf-8"?>
 <p:sld xmlns:a="http://schemas.openxmlformats.org/drawingml/2006/main" xmlns:r="http://schemas.openxmlformats.org/officeDocument/2006/relationships" xmlns:p="http://schemas.openxmlformats.org/presentationml/2006/main">
   <p:cSld>
     <p:spTree>

</xml_diff>